<commit_message>
feat: enhance interaction with voice assistant and gesture control in hackathon deck
Co-authored-by: deepakgangwar1542-hash <237148606+deepakgangwar1542-hash@users.noreply.github.com>
</commit_message>
<xml_diff>
--- a/public/yantraa-hackathon-deck.pptx
+++ b/public/yantraa-hackathon-deck.pptx
@@ -3265,7 +3265,7 @@
                 <a:ea typeface="Arial" pitchFamily="34" charset="-122"/>
                 <a:cs typeface="Arial" pitchFamily="34" charset="-120"/>
               </a:rPr>
-              <a:t>1st &amp; 2nd year engineering students</a:t>
+              <a:t>Engineering students &amp; beginners</a:t>
             </a:r>
             <a:endParaRPr lang="en-US" sz="1500" dirty="0"/>
           </a:p>
@@ -11000,7 +11000,7 @@
                 <a:ea typeface="Arial" pitchFamily="34" charset="-122"/>
                 <a:cs typeface="Arial" pitchFamily="34" charset="-120"/>
               </a:rPr>
-              <a:t>  onto a spatial breadboard.
+              <a:t>  onto a spatial breadboard — or just say what you want.
 </a:t>
             </a:r>
             <a:pPr indent="0" marL="0">
@@ -11035,7 +11035,7 @@
                 <a:ea typeface="Arial" pitchFamily="34" charset="-122"/>
                 <a:cs typeface="Arial" pitchFamily="34" charset="-120"/>
               </a:rPr>
-              <a:t>  with real, snapping jumper wires.
+              <a:t>  with real jumper wires that magnetically snap to the nearest pin.
 </a:t>
             </a:r>
             <a:pPr indent="0" marL="0">
@@ -12026,11 +12026,11 @@
         <p:spPr>
           <a:xfrm>
             <a:off x="822960" y="2286000"/>
-            <a:ext cx="5042916" cy="3291840"/>
+            <a:ext cx="5042916" cy="3566160"/>
           </a:xfrm>
           <a:prstGeom prst="roundRect">
             <a:avLst>
-              <a:gd name="adj" fmla="val 1667"/>
+              <a:gd name="adj" fmla="val 1538"/>
             </a:avLst>
           </a:prstGeom>
           <a:solidFill>
@@ -12281,11 +12281,11 @@
         <p:spPr>
           <a:xfrm>
             <a:off x="6323076" y="2286000"/>
-            <a:ext cx="5042916" cy="3291840"/>
+            <a:ext cx="5042916" cy="3566160"/>
           </a:xfrm>
           <a:prstGeom prst="roundRect">
             <a:avLst>
-              <a:gd name="adj" fmla="val 1667"/>
+              <a:gd name="adj" fmla="val 1538"/>
             </a:avLst>
           </a:prstGeom>
           <a:solidFill>
@@ -12327,7 +12327,7 @@
         </p:nvSpPr>
         <p:spPr>
           <a:xfrm>
-            <a:off x="6597396" y="2514600"/>
+            <a:off x="6597396" y="2487168"/>
             <a:ext cx="4494276" cy="320040"/>
           </a:xfrm>
           <a:prstGeom prst="rect">
@@ -12366,7 +12366,7 @@
         </p:nvSpPr>
         <p:spPr>
           <a:xfrm>
-            <a:off x="6597396" y="3017520"/>
+            <a:off x="6597396" y="2926080"/>
             <a:ext cx="146304" cy="146304"/>
           </a:xfrm>
           <a:prstGeom prst="ellipse">
@@ -12386,7 +12386,7 @@
         </p:nvSpPr>
         <p:spPr>
           <a:xfrm>
-            <a:off x="6890004" y="2971800"/>
+            <a:off x="6890004" y="2880360"/>
             <a:ext cx="4219956" cy="274320"/>
           </a:xfrm>
           <a:prstGeom prst="rect">
@@ -12403,7 +12403,7 @@
               <a:buNone/>
             </a:pPr>
             <a:r>
-              <a:rPr lang="en-US" sz="1500" b="1" dirty="0">
+              <a:rPr lang="en-US" sz="1450" b="1" dirty="0">
                 <a:solidFill>
                   <a:srgbClr val="F4F6F8"/>
                 </a:solidFill>
@@ -12411,9 +12411,9 @@
                 <a:ea typeface="Arial" pitchFamily="34" charset="-122"/>
                 <a:cs typeface="Arial" pitchFamily="34" charset="-120"/>
               </a:rPr>
-              <a:t>Hand-tracking control</a:t>
-            </a:r>
-            <a:endParaRPr lang="en-US" sz="1500" dirty="0"/>
+              <a:t>Voice assistant</a:t>
+            </a:r>
+            <a:endParaRPr lang="en-US" sz="1450" dirty="0"/>
           </a:p>
         </p:txBody>
       </p:sp>
@@ -12425,8 +12425,8 @@
         </p:nvSpPr>
         <p:spPr>
           <a:xfrm>
-            <a:off x="6890004" y="3264408"/>
-            <a:ext cx="4219956" cy="502920"/>
+            <a:off x="6890004" y="3154680"/>
+            <a:ext cx="4219956" cy="457200"/>
           </a:xfrm>
           <a:prstGeom prst="rect">
             <a:avLst/>
@@ -12440,12 +12440,12 @@
           <a:p>
             <a:pPr indent="0" marL="0">
               <a:lnSpc>
-                <a:spcPct val="110000"/>
+                <a:spcPct val="105000"/>
               </a:lnSpc>
               <a:buNone/>
             </a:pPr>
             <a:r>
-              <a:rPr lang="en-US" sz="1250" dirty="0">
+              <a:rPr lang="en-US" sz="1150" dirty="0">
                 <a:solidFill>
                   <a:srgbClr val="A9B2BD"/>
                 </a:solidFill>
@@ -12453,9 +12453,9 @@
                 <a:ea typeface="Arial" pitchFamily="34" charset="-122"/>
                 <a:cs typeface="Arial" pitchFamily="34" charset="-120"/>
               </a:rPr>
-              <a:t>Pinch, grab, and zoom the 3D lab with your webcam — no mouse required.</a:t>
-            </a:r>
-            <a:endParaRPr lang="en-US" sz="1250" dirty="0"/>
+              <a:t>Say “Hey Circuit, add a resistor and wire it to the LED” — it places, connects, and runs it for you.</a:t>
+            </a:r>
+            <a:endParaRPr lang="en-US" sz="1150" dirty="0"/>
           </a:p>
         </p:txBody>
       </p:sp>
@@ -12467,7 +12467,7 @@
         </p:nvSpPr>
         <p:spPr>
           <a:xfrm>
-            <a:off x="6597396" y="3858768"/>
+            <a:off x="6597396" y="3639312"/>
             <a:ext cx="146304" cy="146304"/>
           </a:xfrm>
           <a:prstGeom prst="ellipse">
@@ -12487,7 +12487,7 @@
         </p:nvSpPr>
         <p:spPr>
           <a:xfrm>
-            <a:off x="6890004" y="3813048"/>
+            <a:off x="6890004" y="3593592"/>
             <a:ext cx="4219956" cy="274320"/>
           </a:xfrm>
           <a:prstGeom prst="rect">
@@ -12504,7 +12504,7 @@
               <a:buNone/>
             </a:pPr>
             <a:r>
-              <a:rPr lang="en-US" sz="1500" b="1" dirty="0">
+              <a:rPr lang="en-US" sz="1450" b="1" dirty="0">
                 <a:solidFill>
                   <a:srgbClr val="F4F6F8"/>
                 </a:solidFill>
@@ -12512,9 +12512,9 @@
                 <a:ea typeface="Arial" pitchFamily="34" charset="-122"/>
                 <a:cs typeface="Arial" pitchFamily="34" charset="-120"/>
               </a:rPr>
-              <a:t>Living-schematic UI</a:t>
-            </a:r>
-            <a:endParaRPr lang="en-US" sz="1500" dirty="0"/>
+              <a:t>Hand-tracking control</a:t>
+            </a:r>
+            <a:endParaRPr lang="en-US" sz="1450" dirty="0"/>
           </a:p>
         </p:txBody>
       </p:sp>
@@ -12526,8 +12526,8 @@
         </p:nvSpPr>
         <p:spPr>
           <a:xfrm>
-            <a:off x="6890004" y="4105656"/>
-            <a:ext cx="4219956" cy="502920"/>
+            <a:off x="6890004" y="3867912"/>
+            <a:ext cx="4219956" cy="457200"/>
           </a:xfrm>
           <a:prstGeom prst="rect">
             <a:avLst/>
@@ -12541,12 +12541,12 @@
           <a:p>
             <a:pPr indent="0" marL="0">
               <a:lnSpc>
-                <a:spcPct val="110000"/>
+                <a:spcPct val="105000"/>
               </a:lnSpc>
               <a:buNone/>
             </a:pPr>
             <a:r>
-              <a:rPr lang="en-US" sz="1250" dirty="0">
+              <a:rPr lang="en-US" sz="1150" dirty="0">
                 <a:solidFill>
                   <a:srgbClr val="A9B2BD"/>
                 </a:solidFill>
@@ -12554,9 +12554,9 @@
                 <a:ea typeface="Arial" pitchFamily="34" charset="-122"/>
                 <a:cs typeface="Arial" pitchFamily="34" charset="-120"/>
               </a:rPr>
-              <a:t>The whole app is a powered PCB: glow always means current is flowing.</a:t>
-            </a:r>
-            <a:endParaRPr lang="en-US" sz="1250" dirty="0"/>
+              <a:t>Make a fist to orbit, two fingers to zoom, pinch to grab parts and snap wires — no mouse.</a:t>
+            </a:r>
+            <a:endParaRPr lang="en-US" sz="1150" dirty="0"/>
           </a:p>
         </p:txBody>
       </p:sp>
@@ -12568,7 +12568,7 @@
         </p:nvSpPr>
         <p:spPr>
           <a:xfrm>
-            <a:off x="6597396" y="4700016"/>
+            <a:off x="6597396" y="4352544"/>
             <a:ext cx="146304" cy="146304"/>
           </a:xfrm>
           <a:prstGeom prst="ellipse">
@@ -12588,7 +12588,7 @@
         </p:nvSpPr>
         <p:spPr>
           <a:xfrm>
-            <a:off x="6890004" y="4654296"/>
+            <a:off x="6890004" y="4306824"/>
             <a:ext cx="4219956" cy="274320"/>
           </a:xfrm>
           <a:prstGeom prst="rect">
@@ -12605,7 +12605,7 @@
               <a:buNone/>
             </a:pPr>
             <a:r>
-              <a:rPr lang="en-US" sz="1500" b="1" dirty="0">
+              <a:rPr lang="en-US" sz="1450" b="1" dirty="0">
                 <a:solidFill>
                   <a:srgbClr val="F4F6F8"/>
                 </a:solidFill>
@@ -12613,9 +12613,9 @@
                 <a:ea typeface="Arial" pitchFamily="34" charset="-122"/>
                 <a:cs typeface="Arial" pitchFamily="34" charset="-120"/>
               </a:rPr>
-              <a:t>Runs in the browser</a:t>
-            </a:r>
-            <a:endParaRPr lang="en-US" sz="1500" dirty="0"/>
+              <a:t>Living-schematic UI</a:t>
+            </a:r>
+            <a:endParaRPr lang="en-US" sz="1450" dirty="0"/>
           </a:p>
         </p:txBody>
       </p:sp>
@@ -12627,8 +12627,8 @@
         </p:nvSpPr>
         <p:spPr>
           <a:xfrm>
-            <a:off x="6890004" y="4946904"/>
-            <a:ext cx="4219956" cy="502920"/>
+            <a:off x="6890004" y="4581144"/>
+            <a:ext cx="4219956" cy="457200"/>
           </a:xfrm>
           <a:prstGeom prst="rect">
             <a:avLst/>
@@ -12642,12 +12642,12 @@
           <a:p>
             <a:pPr indent="0" marL="0">
               <a:lnSpc>
-                <a:spcPct val="110000"/>
+                <a:spcPct val="105000"/>
               </a:lnSpc>
               <a:buNone/>
             </a:pPr>
             <a:r>
-              <a:rPr lang="en-US" sz="1250" dirty="0">
+              <a:rPr lang="en-US" sz="1150" dirty="0">
                 <a:solidFill>
                   <a:srgbClr val="A9B2BD"/>
                 </a:solidFill>
@@ -12655,9 +12655,110 @@
                 <a:ea typeface="Arial" pitchFamily="34" charset="-122"/>
                 <a:cs typeface="Arial" pitchFamily="34" charset="-120"/>
               </a:rPr>
+              <a:t>The whole app is a powered PCB: glow always means current is flowing.</a:t>
+            </a:r>
+            <a:endParaRPr lang="en-US" sz="1150" dirty="0"/>
+          </a:p>
+        </p:txBody>
+      </p:sp>
+      <p:sp>
+        <p:nvSpPr>
+          <p:cNvPr id="41" name="Shape 39"/>
+          <p:cNvSpPr/>
+          <p:nvPr/>
+        </p:nvSpPr>
+        <p:spPr>
+          <a:xfrm>
+            <a:off x="6597396" y="5065776"/>
+            <a:ext cx="146304" cy="146304"/>
+          </a:xfrm>
+          <a:prstGeom prst="ellipse">
+            <a:avLst/>
+          </a:prstGeom>
+          <a:solidFill>
+            <a:srgbClr val="2ECC71"/>
+          </a:solidFill>
+          <a:ln/>
+        </p:spPr>
+      </p:sp>
+      <p:sp>
+        <p:nvSpPr>
+          <p:cNvPr id="42" name="Text 40"/>
+          <p:cNvSpPr/>
+          <p:nvPr/>
+        </p:nvSpPr>
+        <p:spPr>
+          <a:xfrm>
+            <a:off x="6890004" y="5020056"/>
+            <a:ext cx="4219956" cy="274320"/>
+          </a:xfrm>
+          <a:prstGeom prst="rect">
+            <a:avLst/>
+          </a:prstGeom>
+          <a:noFill/>
+          <a:ln/>
+        </p:spPr>
+        <p:txBody>
+          <a:bodyPr wrap="square" rtlCol="0" anchor="ctr"/>
+          <a:lstStyle/>
+          <a:p>
+            <a:pPr indent="0" marL="0">
+              <a:buNone/>
+            </a:pPr>
+            <a:r>
+              <a:rPr lang="en-US" sz="1450" b="1" dirty="0">
+                <a:solidFill>
+                  <a:srgbClr val="F4F6F8"/>
+                </a:solidFill>
+                <a:latin typeface="Arial" pitchFamily="34" charset="0"/>
+                <a:ea typeface="Arial" pitchFamily="34" charset="-122"/>
+                <a:cs typeface="Arial" pitchFamily="34" charset="-120"/>
+              </a:rPr>
+              <a:t>Runs in the browser</a:t>
+            </a:r>
+            <a:endParaRPr lang="en-US" sz="1450" dirty="0"/>
+          </a:p>
+        </p:txBody>
+      </p:sp>
+      <p:sp>
+        <p:nvSpPr>
+          <p:cNvPr id="43" name="Text 41"/>
+          <p:cNvSpPr/>
+          <p:nvPr/>
+        </p:nvSpPr>
+        <p:spPr>
+          <a:xfrm>
+            <a:off x="6890004" y="5294376"/>
+            <a:ext cx="4219956" cy="457200"/>
+          </a:xfrm>
+          <a:prstGeom prst="rect">
+            <a:avLst/>
+          </a:prstGeom>
+          <a:noFill/>
+          <a:ln/>
+        </p:spPr>
+        <p:txBody>
+          <a:bodyPr wrap="square" rtlCol="0" anchor="ctr"/>
+          <a:lstStyle/>
+          <a:p>
+            <a:pPr indent="0" marL="0">
+              <a:lnSpc>
+                <a:spcPct val="105000"/>
+              </a:lnSpc>
+              <a:buNone/>
+            </a:pPr>
+            <a:r>
+              <a:rPr lang="en-US" sz="1150" dirty="0">
+                <a:solidFill>
+                  <a:srgbClr val="A9B2BD"/>
+                </a:solidFill>
+                <a:latin typeface="Arial" pitchFamily="34" charset="0"/>
+                <a:ea typeface="Arial" pitchFamily="34" charset="-122"/>
+                <a:cs typeface="Arial" pitchFamily="34" charset="-120"/>
+              </a:rPr>
               <a:t>WebGL 3D + real-time simulation, zero installs, works on a laptop.</a:t>
             </a:r>
-            <a:endParaRPr lang="en-US" sz="1250" dirty="0"/>
+            <a:endParaRPr lang="en-US" sz="1150" dirty="0"/>
           </a:p>
         </p:txBody>
       </p:sp>
@@ -16562,7 +16663,7 @@
                 <a:ea typeface="Consolas" pitchFamily="34" charset="-122"/>
                 <a:cs typeface="Consolas" pitchFamily="34" charset="-120"/>
               </a:rPr>
-              <a:t>HAND TRACKING</a:t>
+              <a:t>GESTURE &amp; VOICE</a:t>
             </a:r>
             <a:endParaRPr lang="en-US" sz="1200" dirty="0"/>
           </a:p>
@@ -16604,7 +16705,7 @@
                 <a:ea typeface="Arial" pitchFamily="34" charset="-122"/>
                 <a:cs typeface="Arial" pitchFamily="34" charset="-120"/>
               </a:rPr>
-              <a:t>Webcam gesture recognition drives pinch / grab / zoom — a natural, mouse-free interface.</a:t>
+              <a:t>Webcam gestures (fist-orbit, pinch-to-wire) and a “Hey Circuit” voice assistant drive the lab hands-free.</a:t>
             </a:r>
             <a:endParaRPr lang="en-US" sz="1200" dirty="0"/>
           </a:p>
@@ -18311,7 +18412,7 @@
                 <a:ea typeface="Arial" pitchFamily="34" charset="-122"/>
                 <a:cs typeface="Arial" pitchFamily="34" charset="-120"/>
               </a:rPr>
-              <a:t>Vercel AI SDK</a:t>
+              <a:t>Vercel AI SDK + Groq</a:t>
             </a:r>
             <a:endParaRPr lang="en-US" sz="1200" dirty="0"/>
           </a:p>
@@ -18370,7 +18471,7 @@
                 <a:ea typeface="Arial" pitchFamily="34" charset="-122"/>
                 <a:cs typeface="Arial" pitchFamily="34" charset="-120"/>
               </a:rPr>
-              <a:t>Groq LLM (streaming)</a:t>
+              <a:t>MediaPipe hand tracking</a:t>
             </a:r>
             <a:endParaRPr lang="en-US" sz="1200" dirty="0"/>
           </a:p>
@@ -18429,7 +18530,7 @@
                 <a:ea typeface="Arial" pitchFamily="34" charset="-122"/>
                 <a:cs typeface="Arial" pitchFamily="34" charset="-120"/>
               </a:rPr>
-              <a:t>MediaPipe hand tracking</a:t>
+              <a:t>Web Speech voice control</a:t>
             </a:r>
             <a:endParaRPr lang="en-US" sz="1200" dirty="0"/>
           </a:p>

</xml_diff>